<commit_message>
chore(assets): regenerate the downloads with the new emblem and name
Rebuild the logos, the social media kit, the social preview image, the
flyer and the slide template from the updated emblem and content, and
update the conference name and the topics in the Call for Papers slides.

Co-Authored-By: Claude Opus 5.5 <noreply@anthropic.com>
</commit_message>
<xml_diff>
--- a/web/static/files/ICAS-Call-for-Papers.pptx
+++ b/web/static/files/ICAS-Call-for-Papers.pptx
@@ -3375,7 +3375,7 @@
                 <a:latin typeface="jf open 粉圓 2.0" panose="020B0000000000000000" pitchFamily="34" charset="-120"/>
                 <a:ea typeface="jf open 粉圓 2.0" panose="020B0000000000000000" pitchFamily="34" charset="-120"/>
               </a:rPr>
-              <a:t>on Autonomous System, ICAS</a:t>
+              <a:t>on Autonomous Systems, ICAS</a:t>
             </a:r>
             <a:br>
               <a:rPr lang="en-US" altLang="zh-TW" dirty="0">
@@ -4374,7 +4374,7 @@
         </p:spPr>
         <p:txBody>
           <a:bodyPr>
-            <a:normAutofit fontScale="32500" lnSpcReduction="20000"/>
+            <a:normAutofit fontScale="30000" lnSpcReduction="20000"/>
           </a:bodyPr>
           <a:lstStyle/>
           <a:p>
@@ -4408,7 +4408,24 @@
                 <a:latin typeface="jf open 粉圓 2.0" panose="020B0000000000000000" pitchFamily="34" charset="-120"/>
                 <a:ea typeface="jf open 粉圓 2.0" panose="020B0000000000000000" pitchFamily="34" charset="-120"/>
               </a:rPr>
-              <a:t>: self-driving cars, UAVs, unmanned surface and underwater vehicles, space autonomy.</a:t>
+              <a:t>: self-driving cars, unmanned ground, surface and underwater vehicles, space autonomy.</a:t>
+            </a:r>
+          </a:p>
+          <a:p>
+            <a:pPr lvl="0"/>
+            <a:r>
+              <a:rPr lang="zh-TW" altLang="zh-TW" sz="4000" b="1" dirty="0">
+                <a:latin typeface="jf open 粉圓 2.0" panose="020B0000000000000000" pitchFamily="34" charset="-120"/>
+                <a:ea typeface="jf open 粉圓 2.0" panose="020B0000000000000000" pitchFamily="34" charset="-120"/>
+              </a:rPr>
+              <a:t>Drones and Aerial Autonomy</a:t>
+            </a:r>
+            <a:r>
+              <a:rPr lang="zh-TW" altLang="zh-TW" sz="4000" dirty="0">
+                <a:latin typeface="jf open 粉圓 2.0" panose="020B0000000000000000" pitchFamily="34" charset="-120"/>
+                <a:ea typeface="jf open 粉圓 2.0" panose="020B0000000000000000" pitchFamily="34" charset="-120"/>
+              </a:rPr>
+              <a:t>: multirotor and fixed-wing UAVs, autonomous flight control, aerial mapping and inspection, drone swarms, beyond-visual-line-of-sight operations.</a:t>
             </a:r>
           </a:p>
           <a:p>

</xml_diff>